<commit_message>
Update report and slides for the website
Replace Streamlit screenshots with captures of the new website, rewrite
the architecture, UI and testing sections of the report, update slide 8
and the demo script, and rebuild report.docx, report.pdf and
presentation.pptx.
</commit_message>
<xml_diff>
--- a/presentation.pptx
+++ b/presentation.pptx
@@ -1071,7 +1071,7 @@
           <a:lstStyle/>
           <a:p>
             <a:r>
-              <a:t>Live demo: on Configure, set q to 0.70 and show two equilibria appear; then show the simulator's unilateral-deviation panels.</a:t>
+              <a:t>Live demo: in Play, set both stations to ₹12 and show each gains ₹200 by switching. In Analysis, every arrow points to (₹10, ₹10); press Present full screen. Open Change the market, set q to 0.70 and show two equilibria and the 50/50 mixed strategy. Then Restore baseline.</a:t>
             </a:r>
           </a:p>
         </p:txBody>
@@ -4657,7 +4657,7 @@
                 </a:solidFill>
                 <a:latin typeface="Calibri"/>
               </a:rPr>
-              <a:t>•  All results are computed, tested and explorable in the dashboard.</a:t>
+              <a:t>•  All results are computed, tested and explorable on the website.</a:t>
             </a:r>
           </a:p>
         </p:txBody>
@@ -7427,7 +7427,7 @@
                 </a:solidFill>
                 <a:latin typeface="Calibri"/>
               </a:rPr>
-              <a:t>Interactive Streamlit dashboard</a:t>
+              <a:t>An interactive website anyone can play</a:t>
             </a:r>
           </a:p>
         </p:txBody>
@@ -7469,7 +7469,7 @@
       </p:sp>
       <p:pic>
         <p:nvPicPr>
-          <p:cNvPr id="6" name="Picture 5" descr="02_payoff_matrix.png"/>
+          <p:cNvPr id="6" name="Picture 5" descr="web_04_analysis.png"/>
           <p:cNvPicPr>
             <a:picLocks noChangeAspect="1"/>
           </p:cNvPicPr>
@@ -7484,7 +7484,7 @@
         <p:spPr>
           <a:xfrm>
             <a:off x="548640" y="1600200"/>
-            <a:ext cx="5577840" cy="3122041"/>
+            <a:ext cx="3983875" cy="3246120"/>
           </a:xfrm>
           <a:prstGeom prst="rect">
             <a:avLst/>
@@ -7493,7 +7493,7 @@
       </p:pic>
       <p:pic>
         <p:nvPicPr>
-          <p:cNvPr id="7" name="Picture 6" descr="03_simulator.png"/>
+          <p:cNvPr id="7" name="Picture 6" descr="web_03_simulator.png"/>
           <p:cNvPicPr>
             <a:picLocks noChangeAspect="1"/>
           </p:cNvPicPr>
@@ -7507,8 +7507,8 @@
         </p:blipFill>
         <p:spPr>
           <a:xfrm>
-            <a:off x="6309360" y="1600200"/>
-            <a:ext cx="5577840" cy="3122041"/>
+            <a:off x="4937760" y="1600200"/>
+            <a:ext cx="5520960" cy="3246120"/>
           </a:xfrm>
           <a:prstGeom prst="rect">
             <a:avLst/>
@@ -7523,7 +7523,7 @@
         </p:nvSpPr>
         <p:spPr>
           <a:xfrm>
-            <a:off x="548640" y="4892040"/>
+            <a:off x="548640" y="4983480"/>
             <a:ext cx="11247120" cy="1463040"/>
           </a:xfrm>
           <a:prstGeom prst="rect">
@@ -7557,7 +7557,7 @@
                 </a:solidFill>
                 <a:latin typeface="Calibri"/>
               </a:rPr>
-              <a:t>app.py + visualizations.py: 8 pages in Streamlit and Plotly  ·  pytest suite on the model</a:t>
+              <a:t>web/: Vite + GSAP site; model.js runs the same model in the browser  ·  49 pytest tests incl. JS parity</a:t>
             </a:r>
           </a:p>
           <a:p>
@@ -7569,7 +7569,7 @@
                 </a:solidFill>
                 <a:latin typeface="Calibri"/>
               </a:rPr>
-              <a:t>Run locally:  streamlit run app.py</a:t>
+              <a:t>Run locally:  cd web &amp;&amp; npm install &amp;&amp; npm run dev</a:t>
             </a:r>
           </a:p>
         </p:txBody>

</xml_diff>

<commit_message>
Correct Arnav Khandelwal's student ID to 2427030196
</commit_message>
<xml_diff>
--- a/presentation.pptx
+++ b/presentation.pptx
@@ -4380,7 +4380,7 @@
                 </a:solidFill>
                 <a:latin typeface="Calibri"/>
               </a:rPr>
-              <a:t>Arnav Khandelwal  ·  242703019</a:t>
+              <a:t>Arnav Khandelwal  ·  2427030196</a:t>
             </a:r>
           </a:p>
           <a:p>
@@ -7484,7 +7484,7 @@
         <p:spPr>
           <a:xfrm>
             <a:off x="548640" y="1600200"/>
-            <a:ext cx="3983875" cy="3246120"/>
+            <a:ext cx="3985007" cy="3246120"/>
           </a:xfrm>
           <a:prstGeom prst="rect">
             <a:avLst/>
@@ -7508,7 +7508,7 @@
         <p:spPr>
           <a:xfrm>
             <a:off x="4937760" y="1600200"/>
-            <a:ext cx="5520960" cy="3246120"/>
+            <a:ext cx="5518787" cy="3246120"/>
           </a:xfrm>
           <a:prstGeom prst="rect">
             <a:avLst/>

</xml_diff>

<commit_message>
Add faculty (Dr Soni Gupta), remove submission date
</commit_message>
<xml_diff>
--- a/presentation.pptx
+++ b/presentation.pptx
@@ -4405,6 +4405,41 @@
                 <a:latin typeface="Calibri"/>
               </a:rPr>
               <a:t>Khushi Yadav  ·  2427030186</a:t>
+            </a:r>
+          </a:p>
+        </p:txBody>
+      </p:sp>
+      <p:sp>
+        <p:nvSpPr>
+          <p:cNvPr id="8" name="TextBox 7"/>
+          <p:cNvSpPr txBox="1"/>
+          <p:nvPr/>
+        </p:nvSpPr>
+        <p:spPr>
+          <a:xfrm>
+            <a:off x="8046720" y="4663440"/>
+            <a:ext cx="3657600" cy="457200"/>
+          </a:xfrm>
+          <a:prstGeom prst="rect">
+            <a:avLst/>
+          </a:prstGeom>
+          <a:noFill/>
+        </p:spPr>
+        <p:txBody>
+          <a:bodyPr wrap="square">
+            <a:spAutoFit/>
+          </a:bodyPr>
+          <a:lstStyle/>
+          <a:p>
+            <a:pPr algn="l"/>
+            <a:r>
+              <a:rPr sz="1600" b="0">
+                <a:solidFill>
+                  <a:srgbClr val="D5E6EA"/>
+                </a:solidFill>
+                <a:latin typeface="Calibri"/>
+              </a:rPr>
+              <a:t>Faculty: Dr Soni Gupta</a:t>
             </a:r>
           </a:p>
         </p:txBody>

</xml_diff>